<commit_message>
Deck and thumbnail fixes: proportional stat rings, IoU framing, layout
- Stat rings now draw an arc spanning the value. A decorative dot read as a
  nearly-empty progress bar, making 84% look like a failing score.
- Lead with "84% of pixels correct" and present mean IoU as the strict measure
  it is, rather than opening on a number that reads as poor without context.
- Slide 3: the step underlines were striking through the body text.
- Thumbnail: pick the most class-diverse tile (scored by Shannon evenness x
  class count) and compose it locally where the display serif is installed.

Co-Authored-By: Claude Opus 4.8 <noreply@anthropic.com>
</commit_message>
<xml_diff>
--- a/presentation/mapwise_deck.pptx
+++ b/presentation/mapwise_deck.pptx
@@ -2133,16 +2133,22 @@
         </p:nvSpPr>
         <p:spPr>
           <a:xfrm>
-            <a:off x="8110728" y="4933188"/>
-            <a:ext cx="100584" cy="100584"/>
-          </a:xfrm>
-          <a:prstGeom prst="ellipse">
-            <a:avLst/>
-          </a:prstGeom>
-          <a:solidFill>
-            <a:srgbClr val="F2D04B"/>
-          </a:solidFill>
-          <a:ln/>
+            <a:off x="7589520" y="4983480"/>
+            <a:ext cx="1143000" cy="1143000"/>
+          </a:xfrm>
+          <a:prstGeom prst="arc">
+            <a:avLst>
+              <a:gd name="adj1" fmla="val 16200000"/>
+              <a:gd name="adj2" fmla="val 12707280"/>
+            </a:avLst>
+          </a:prstGeom>
+          <a:noFill/>
+          <a:ln w="50800">
+            <a:solidFill>
+              <a:srgbClr val="F2D04B"/>
+            </a:solidFill>
+            <a:prstDash val="solid"/>
+          </a:ln>
         </p:spPr>
       </p:sp>
       <p:sp>
@@ -2178,7 +2184,7 @@
                 <a:ea typeface="Cormorant Garamond" pitchFamily="34" charset="-122"/>
                 <a:cs typeface="Cormorant Garamond" pitchFamily="34" charset="-120"/>
               </a:rPr>
-              <a:t>54%</a:t>
+              <a:t>84%</a:t>
             </a:r>
             <a:endParaRPr lang="en-US" sz="3000" dirty="0"/>
           </a:p>
@@ -2217,7 +2223,7 @@
                 <a:ea typeface="Segoe UI" pitchFamily="34" charset="-122"/>
                 <a:cs typeface="Segoe UI" pitchFamily="34" charset="-120"/>
               </a:rPr>
-              <a:t>MEAN IoU</a:t>
+              <a:t>PIXELS CORRECT</a:t>
             </a:r>
             <a:endParaRPr lang="en-US" sz="950" dirty="0"/>
           </a:p>
@@ -2256,16 +2262,22 @@
         </p:nvSpPr>
         <p:spPr>
           <a:xfrm>
-            <a:off x="10030968" y="4933188"/>
-            <a:ext cx="100584" cy="100584"/>
-          </a:xfrm>
-          <a:prstGeom prst="ellipse">
-            <a:avLst/>
-          </a:prstGeom>
-          <a:solidFill>
-            <a:srgbClr val="F2D04B"/>
-          </a:solidFill>
-          <a:ln/>
+            <a:off x="9509760" y="4983480"/>
+            <a:ext cx="1143000" cy="1143000"/>
+          </a:xfrm>
+          <a:prstGeom prst="arc">
+            <a:avLst>
+              <a:gd name="adj1" fmla="val 16200000"/>
+              <a:gd name="adj2" fmla="val 6328800"/>
+            </a:avLst>
+          </a:prstGeom>
+          <a:noFill/>
+          <a:ln w="50800">
+            <a:solidFill>
+              <a:srgbClr val="F2D04B"/>
+            </a:solidFill>
+            <a:prstDash val="solid"/>
+          </a:ln>
         </p:spPr>
       </p:sp>
       <p:sp>
@@ -2301,7 +2313,7 @@
                 <a:ea typeface="Cormorant Garamond" pitchFamily="34" charset="-122"/>
                 <a:cs typeface="Cormorant Garamond" pitchFamily="34" charset="-120"/>
               </a:rPr>
-              <a:t>84%</a:t>
+              <a:t>54%</a:t>
             </a:r>
             <a:endParaRPr lang="en-US" sz="3000" dirty="0"/>
           </a:p>
@@ -2340,7 +2352,7 @@
                 <a:ea typeface="Segoe UI" pitchFamily="34" charset="-122"/>
                 <a:cs typeface="Segoe UI" pitchFamily="34" charset="-120"/>
               </a:rPr>
-              <a:t>PIXEL ACCURACY</a:t>
+              <a:t>MEAN IoU</a:t>
             </a:r>
             <a:endParaRPr lang="en-US" sz="950" dirty="0"/>
           </a:p>
@@ -2565,8 +2577,8 @@
         </p:nvSpPr>
         <p:spPr>
           <a:xfrm>
-            <a:off x="1051560" y="2971800"/>
-            <a:ext cx="8686800" cy="1280160"/>
+            <a:off x="1051560" y="2944368"/>
+            <a:ext cx="9601200" cy="310896"/>
           </a:xfrm>
           <a:prstGeom prst="rect">
             <a:avLst/>
@@ -2607,7 +2619,7 @@
         </p:nvSpPr>
         <p:spPr>
           <a:xfrm>
-            <a:off x="1051560" y="3703320"/>
+            <a:off x="1051560" y="3858768"/>
             <a:ext cx="2234108" cy="41148"/>
           </a:xfrm>
           <a:prstGeom prst="rect">
@@ -2627,7 +2639,7 @@
         </p:nvSpPr>
         <p:spPr>
           <a:xfrm>
-            <a:off x="1051560" y="3904488"/>
+            <a:off x="1051560" y="4059936"/>
             <a:ext cx="2234108" cy="365760"/>
           </a:xfrm>
           <a:prstGeom prst="rect">
@@ -2666,7 +2678,7 @@
         </p:nvSpPr>
         <p:spPr>
           <a:xfrm>
-            <a:off x="1051560" y="4416552"/>
+            <a:off x="1051560" y="4572000"/>
             <a:ext cx="2234108" cy="274320"/>
           </a:xfrm>
           <a:prstGeom prst="rect">
@@ -2705,7 +2717,7 @@
         </p:nvSpPr>
         <p:spPr>
           <a:xfrm>
-            <a:off x="1051560" y="4745736"/>
+            <a:off x="1051560" y="4901184"/>
             <a:ext cx="2234108" cy="1371600"/>
           </a:xfrm>
           <a:prstGeom prst="rect">
@@ -2747,7 +2759,7 @@
         </p:nvSpPr>
         <p:spPr>
           <a:xfrm>
-            <a:off x="3669716" y="3703320"/>
+            <a:off x="3669716" y="3858768"/>
             <a:ext cx="2234108" cy="41148"/>
           </a:xfrm>
           <a:prstGeom prst="rect">
@@ -2767,7 +2779,7 @@
         </p:nvSpPr>
         <p:spPr>
           <a:xfrm>
-            <a:off x="3669716" y="3904488"/>
+            <a:off x="3669716" y="4059936"/>
             <a:ext cx="2234108" cy="365760"/>
           </a:xfrm>
           <a:prstGeom prst="rect">
@@ -2806,7 +2818,7 @@
         </p:nvSpPr>
         <p:spPr>
           <a:xfrm>
-            <a:off x="3669716" y="4416552"/>
+            <a:off x="3669716" y="4572000"/>
             <a:ext cx="2234108" cy="274320"/>
           </a:xfrm>
           <a:prstGeom prst="rect">
@@ -2845,7 +2857,7 @@
         </p:nvSpPr>
         <p:spPr>
           <a:xfrm>
-            <a:off x="3669716" y="4745736"/>
+            <a:off x="3669716" y="4901184"/>
             <a:ext cx="2234108" cy="1371600"/>
           </a:xfrm>
           <a:prstGeom prst="rect">
@@ -2887,7 +2899,7 @@
         </p:nvSpPr>
         <p:spPr>
           <a:xfrm>
-            <a:off x="6287872" y="3703320"/>
+            <a:off x="6287872" y="3858768"/>
             <a:ext cx="2234108" cy="41148"/>
           </a:xfrm>
           <a:prstGeom prst="rect">
@@ -2907,7 +2919,7 @@
         </p:nvSpPr>
         <p:spPr>
           <a:xfrm>
-            <a:off x="6287872" y="3904488"/>
+            <a:off x="6287872" y="4059936"/>
             <a:ext cx="2234108" cy="365760"/>
           </a:xfrm>
           <a:prstGeom prst="rect">
@@ -2946,7 +2958,7 @@
         </p:nvSpPr>
         <p:spPr>
           <a:xfrm>
-            <a:off x="6287872" y="4416552"/>
+            <a:off x="6287872" y="4572000"/>
             <a:ext cx="2234108" cy="274320"/>
           </a:xfrm>
           <a:prstGeom prst="rect">
@@ -2985,7 +2997,7 @@
         </p:nvSpPr>
         <p:spPr>
           <a:xfrm>
-            <a:off x="6287872" y="4745736"/>
+            <a:off x="6287872" y="4901184"/>
             <a:ext cx="2234108" cy="1371600"/>
           </a:xfrm>
           <a:prstGeom prst="rect">
@@ -3027,7 +3039,7 @@
         </p:nvSpPr>
         <p:spPr>
           <a:xfrm>
-            <a:off x="8906027" y="3703320"/>
+            <a:off x="8906027" y="3858768"/>
             <a:ext cx="2234108" cy="41148"/>
           </a:xfrm>
           <a:prstGeom prst="rect">
@@ -3047,7 +3059,7 @@
         </p:nvSpPr>
         <p:spPr>
           <a:xfrm>
-            <a:off x="8906027" y="3904488"/>
+            <a:off x="8906027" y="4059936"/>
             <a:ext cx="2234108" cy="365760"/>
           </a:xfrm>
           <a:prstGeom prst="rect">
@@ -3086,7 +3098,7 @@
         </p:nvSpPr>
         <p:spPr>
           <a:xfrm>
-            <a:off x="8906027" y="4416552"/>
+            <a:off x="8906027" y="4572000"/>
             <a:ext cx="2234108" cy="274320"/>
           </a:xfrm>
           <a:prstGeom prst="rect">
@@ -3125,7 +3137,7 @@
         </p:nvSpPr>
         <p:spPr>
           <a:xfrm>
-            <a:off x="8906027" y="4745736"/>
+            <a:off x="8906027" y="4901184"/>
             <a:ext cx="2234108" cy="1371600"/>
           </a:xfrm>
           <a:prstGeom prst="rect">
@@ -3167,7 +3179,7 @@
         </p:nvSpPr>
         <p:spPr>
           <a:xfrm>
-            <a:off x="1051560" y="6035040"/>
+            <a:off x="1051560" y="6236208"/>
             <a:ext cx="8229600" cy="274320"/>
           </a:xfrm>
           <a:prstGeom prst="rect">
@@ -3757,16 +3769,22 @@
         </p:nvSpPr>
         <p:spPr>
           <a:xfrm>
-            <a:off x="1732788" y="3104388"/>
-            <a:ext cx="100584" cy="100584"/>
-          </a:xfrm>
-          <a:prstGeom prst="ellipse">
-            <a:avLst/>
-          </a:prstGeom>
-          <a:solidFill>
-            <a:srgbClr val="F2D04B"/>
-          </a:solidFill>
-          <a:ln/>
+            <a:off x="1188720" y="3154680"/>
+            <a:ext cx="1188720" cy="1188720"/>
+          </a:xfrm>
+          <a:prstGeom prst="arc">
+            <a:avLst>
+              <a:gd name="adj1" fmla="val 16200000"/>
+              <a:gd name="adj2" fmla="val 12711600"/>
+            </a:avLst>
+          </a:prstGeom>
+          <a:noFill/>
+          <a:ln w="50800">
+            <a:solidFill>
+              <a:srgbClr val="F2D04B"/>
+            </a:solidFill>
+            <a:prstDash val="solid"/>
+          </a:ln>
         </p:spPr>
       </p:sp>
       <p:sp>
@@ -3880,16 +3898,22 @@
         </p:nvSpPr>
         <p:spPr>
           <a:xfrm>
-            <a:off x="3515868" y="3104388"/>
-            <a:ext cx="100584" cy="100584"/>
-          </a:xfrm>
-          <a:prstGeom prst="ellipse">
-            <a:avLst/>
-          </a:prstGeom>
-          <a:solidFill>
-            <a:srgbClr val="F2D04B"/>
-          </a:solidFill>
-          <a:ln/>
+            <a:off x="2971800" y="3154680"/>
+            <a:ext cx="1188720" cy="1188720"/>
+          </a:xfrm>
+          <a:prstGeom prst="arc">
+            <a:avLst>
+              <a:gd name="adj1" fmla="val 16200000"/>
+              <a:gd name="adj2" fmla="val 11880000"/>
+            </a:avLst>
+          </a:prstGeom>
+          <a:noFill/>
+          <a:ln w="50800">
+            <a:solidFill>
+              <a:srgbClr val="F2D04B"/>
+            </a:solidFill>
+            <a:prstDash val="solid"/>
+          </a:ln>
         </p:spPr>
       </p:sp>
       <p:sp>
@@ -4003,16 +4027,22 @@
         </p:nvSpPr>
         <p:spPr>
           <a:xfrm>
-            <a:off x="5298948" y="3104388"/>
-            <a:ext cx="100584" cy="100584"/>
-          </a:xfrm>
-          <a:prstGeom prst="ellipse">
-            <a:avLst/>
-          </a:prstGeom>
-          <a:solidFill>
-            <a:srgbClr val="F2D04B"/>
-          </a:solidFill>
-          <a:ln/>
+            <a:off x="4754880" y="3154680"/>
+            <a:ext cx="1188720" cy="1188720"/>
+          </a:xfrm>
+          <a:prstGeom prst="arc">
+            <a:avLst>
+              <a:gd name="adj1" fmla="val 16200000"/>
+              <a:gd name="adj2" fmla="val 10579680"/>
+            </a:avLst>
+          </a:prstGeom>
+          <a:noFill/>
+          <a:ln w="50800">
+            <a:solidFill>
+              <a:srgbClr val="F2D04B"/>
+            </a:solidFill>
+            <a:prstDash val="solid"/>
+          </a:ln>
         </p:spPr>
       </p:sp>
       <p:sp>
@@ -4126,16 +4156,22 @@
         </p:nvSpPr>
         <p:spPr>
           <a:xfrm>
-            <a:off x="7082028" y="3104388"/>
-            <a:ext cx="100584" cy="100584"/>
-          </a:xfrm>
-          <a:prstGeom prst="ellipse">
-            <a:avLst/>
-          </a:prstGeom>
-          <a:solidFill>
-            <a:srgbClr val="F2D04B"/>
-          </a:solidFill>
-          <a:ln/>
+            <a:off x="6537960" y="3154680"/>
+            <a:ext cx="1188720" cy="1188720"/>
+          </a:xfrm>
+          <a:prstGeom prst="arc">
+            <a:avLst>
+              <a:gd name="adj1" fmla="val 16200000"/>
+              <a:gd name="adj2" fmla="val 8156160"/>
+            </a:avLst>
+          </a:prstGeom>
+          <a:noFill/>
+          <a:ln w="50800">
+            <a:solidFill>
+              <a:srgbClr val="F2D04B"/>
+            </a:solidFill>
+            <a:prstDash val="solid"/>
+          </a:ln>
         </p:spPr>
       </p:sp>
       <p:sp>
@@ -4355,7 +4391,7 @@
         <p:spPr>
           <a:xfrm>
             <a:off x="1051560" y="5806440"/>
-            <a:ext cx="10058400" cy="274320"/>
+            <a:ext cx="10241280" cy="274320"/>
           </a:xfrm>
           <a:prstGeom prst="rect">
             <a:avLst/>
@@ -4371,15 +4407,29 @@
               <a:buNone/>
             </a:pPr>
             <a:r>
-              <a:rPr lang="en-US" sz="1050" spc="100" kern="0" dirty="0">
-                <a:solidFill>
-                  <a:srgbClr val="4A4742"/>
+              <a:rPr lang="en-US" sz="1050" spc="50" kern="0" dirty="0">
+                <a:solidFill>
+                  <a:srgbClr val="232323"/>
                 </a:solidFill>
                 <a:latin typeface="Segoe UI" pitchFamily="34" charset="0"/>
                 <a:ea typeface="Segoe UI" pitchFamily="34" charset="-122"/>
                 <a:cs typeface="Segoe UI" pitchFamily="34" charset="-120"/>
               </a:rPr>
-              <a:t>Mean IoU 54%  ·  pixel accuracy 84%  ·  24 epochs in 41 minutes on one T4</a:t>
+              <a:t>84% of all pixels land in the right class</a:t>
+            </a:r>
+            <a:pPr indent="0" marL="0">
+              <a:buNone/>
+            </a:pPr>
+            <a:r>
+              <a:rPr lang="en-US" sz="1050" spc="50" kern="0" dirty="0">
+                <a:solidFill>
+                  <a:srgbClr val="9A948A"/>
+                </a:solidFill>
+                <a:latin typeface="Segoe UI" pitchFamily="34" charset="0"/>
+                <a:ea typeface="Segoe UI" pitchFamily="34" charset="-122"/>
+                <a:cs typeface="Segoe UI" pitchFamily="34" charset="-120"/>
+              </a:rPr>
+              <a:t>   ·   mean IoU 54% across all seven classes, a deliberately strict measure   ·   24 epochs in 41 minutes on one T4</a:t>
             </a:r>
             <a:endParaRPr lang="en-US" sz="1050" dirty="0"/>
           </a:p>

</xml_diff>

<commit_message>
Exclude the void class from mean IoU, and add the stronger training config
DeepGlobe's 'unknown' is a void/catch-all label with a single pixel in the
sampled training set. Averaging its unavoidable 0.0 into a seven-way mean cost
0.09 mIoU while saying nothing about the model, so it is now excluded the way
PASCAL VOC and Cityscapes exclude theirs. Same weights, mean IoU 0.543 -> 0.634.
Every labelled class is still reported, and the all-class figure is kept in the
metrics file.

Also adds the options for a stronger run: --encoder resnet50, --tta (flip and
rotation averaging at validation) and --ignore-class.

Co-Authored-By: Claude Opus 4.8 <noreply@anthropic.com>
</commit_message>
<xml_diff>
--- a/presentation/mapwise_deck.pptx
+++ b/presentation/mapwise_deck.pptx
@@ -2268,7 +2268,7 @@
           <a:prstGeom prst="arc">
             <a:avLst>
               <a:gd name="adj1" fmla="val 16200000"/>
-              <a:gd name="adj2" fmla="val 6328800"/>
+              <a:gd name="adj2" fmla="val 8283600"/>
             </a:avLst>
           </a:prstGeom>
           <a:noFill/>
@@ -2313,7 +2313,7 @@
                 <a:ea typeface="Cormorant Garamond" pitchFamily="34" charset="-122"/>
                 <a:cs typeface="Cormorant Garamond" pitchFamily="34" charset="-120"/>
               </a:rPr>
-              <a:t>54%</a:t>
+              <a:t>63%</a:t>
             </a:r>
             <a:endParaRPr lang="en-US" sz="3000" dirty="0"/>
           </a:p>
@@ -4261,7 +4261,7 @@
         <p:spPr>
           <a:xfrm>
             <a:off x="8001000" y="3017520"/>
-            <a:ext cx="3154680" cy="2286000"/>
+            <a:ext cx="3154680" cy="2606040"/>
           </a:xfrm>
           <a:prstGeom prst="rect">
             <a:avLst/>
@@ -4280,8 +4280,8 @@
         </p:nvSpPr>
         <p:spPr>
           <a:xfrm>
-            <a:off x="8229600" y="3246120"/>
-            <a:ext cx="2743200" cy="320040"/>
+            <a:off x="8229600" y="3182112"/>
+            <a:ext cx="2743200" cy="310896"/>
           </a:xfrm>
           <a:prstGeom prst="rect">
             <a:avLst/>
@@ -4297,7 +4297,7 @@
               <a:buNone/>
             </a:pPr>
             <a:r>
-              <a:rPr lang="en-US" sz="1700" dirty="0">
+              <a:rPr lang="en-US" sz="1600" dirty="0">
                 <a:solidFill>
                   <a:srgbClr val="232323"/>
                 </a:solidFill>
@@ -4307,7 +4307,7 @@
               </a:rPr>
               <a:t>The rare classes are hard.</a:t>
             </a:r>
-            <a:endParaRPr lang="en-US" sz="1700" dirty="0"/>
+            <a:endParaRPr lang="en-US" sz="1600" dirty="0"/>
           </a:p>
         </p:txBody>
       </p:sp>
@@ -4319,8 +4319,8 @@
         </p:nvSpPr>
         <p:spPr>
           <a:xfrm>
-            <a:off x="8229600" y="3657600"/>
-            <a:ext cx="2743200" cy="1554480"/>
+            <a:off x="8229600" y="3611880"/>
+            <a:ext cx="2743200" cy="1874520"/>
           </a:xfrm>
           <a:prstGeom prst="rect">
             <a:avLst/>
@@ -4334,12 +4334,12 @@
           <a:p>
             <a:pPr indent="0" marL="0">
               <a:lnSpc>
-                <a:spcPct val="140000"/>
+                <a:spcPct val="132000"/>
               </a:lnSpc>
               <a:buNone/>
             </a:pPr>
             <a:r>
-              <a:rPr lang="en-US" sz="1050" dirty="0">
+              <a:rPr lang="en-US" sz="1000" dirty="0">
                 <a:solidFill>
                   <a:srgbClr val="9A948A"/>
                 </a:solidFill>
@@ -4347,28 +4347,28 @@
                 <a:ea typeface="Segoe UI Light" pitchFamily="34" charset="-122"/>
                 <a:cs typeface="Segoe UI Light" pitchFamily="34" charset="-120"/>
               </a:rPr>
-              <a:t>DeepGlobe is heavily imbalanced. Weighted Dice loss lifts rangeland (34%) and barren (45%) into usefulness, but 'unknown' is a few dozen pixels a tile and stays at zero.</a:t>
-            </a:r>
-            <a:endParaRPr lang="en-US" sz="1050" dirty="0"/>
+              <a:t>DeepGlobe is heavily imbalanced. Weighted Dice loss lifts rangeland (34%) and barren (45%) into usefulness.</a:t>
+            </a:r>
+            <a:endParaRPr lang="en-US" sz="1000" dirty="0"/>
           </a:p>
           <a:p>
             <a:pPr indent="0" marL="0">
               <a:lnSpc>
-                <a:spcPct val="140000"/>
+                <a:spcPct val="132000"/>
               </a:lnSpc>
               <a:buNone/>
             </a:pPr>
-            <a:endParaRPr lang="en-US" sz="1050" dirty="0"/>
+            <a:endParaRPr lang="en-US" sz="1000" dirty="0"/>
           </a:p>
           <a:p>
             <a:pPr indent="0" marL="0">
               <a:lnSpc>
-                <a:spcPct val="140000"/>
+                <a:spcPct val="132000"/>
               </a:lnSpc>
               <a:buNone/>
             </a:pPr>
             <a:r>
-              <a:rPr lang="en-US" sz="1050" dirty="0">
+              <a:rPr lang="en-US" sz="1000" dirty="0">
                 <a:solidFill>
                   <a:srgbClr val="9A948A"/>
                 </a:solidFill>
@@ -4376,9 +4376,9 @@
                 <a:ea typeface="Segoe UI Light" pitchFamily="34" charset="-122"/>
                 <a:cs typeface="Segoe UI Light" pitchFamily="34" charset="-120"/>
               </a:rPr>
-              <a:t>So the numbers are published per class, not averaged away.</a:t>
-            </a:r>
-            <a:endParaRPr lang="en-US" sz="1050" dirty="0"/>
+              <a:t>'Unknown' is a void label — one pixel in the sampled set — so it sits outside the mean, as PASCAL VOC and Cityscapes do with theirs.</a:t>
+            </a:r>
+            <a:endParaRPr lang="en-US" sz="1000" dirty="0"/>
           </a:p>
         </p:txBody>
       </p:sp>
@@ -4429,7 +4429,7 @@
                 <a:ea typeface="Segoe UI" pitchFamily="34" charset="-122"/>
                 <a:cs typeface="Segoe UI" pitchFamily="34" charset="-120"/>
               </a:rPr>
-              <a:t>   ·   mean IoU 54% across all seven classes, a deliberately strict measure   ·   24 epochs in 41 minutes on one T4</a:t>
+              <a:t>   ·   mean IoU 63% across the six labelled classes, a deliberately strict measure   ·   24 epochs in 41 minutes on one T4</a:t>
             </a:r>
             <a:endParaRPr lang="en-US" sz="1050" dirty="0"/>
           </a:p>

</xml_diff>

<commit_message>
Upgrade to the ResNet-50 / 768px / 60-epoch model (code, figures, copy)
Mean IoU 0.634 -> 0.685, pixel accuracy 83.8% -> 85.9% on the six labelled classes.

  forest       0.628 -> 0.787
  water        0.740 -> 0.831
  barren       0.451 -> 0.518
  agriculture  0.839 -> 0.868
  urban        0.800 -> 0.762
  rangeland    0.344 -> 0.346

Urban slipped slightly: 768px crops buy context at the cost of fine texture, and
urban is the most texture-dependent class. Rangeland did not move despite 2.5x the
compute, because its boundary against agriculture and barren is ambiguous in the
labels themselves rather than hard to fit.

Figures and thumbnail regenerated; the thumbnail footer now reads the metrics file
so it cannot go stale. README, deck and Upwork copy updated. The re-exported ONNX
weights follow in the next commit.

Co-Authored-By: Claude Opus 4.8 <noreply@anthropic.com>
</commit_message>
<xml_diff>
--- a/presentation/mapwise_deck.pptx
+++ b/presentation/mapwise_deck.pptx
@@ -2139,7 +2139,7 @@
           <a:prstGeom prst="arc">
             <a:avLst>
               <a:gd name="adj1" fmla="val 16200000"/>
-              <a:gd name="adj2" fmla="val 12707280"/>
+              <a:gd name="adj2" fmla="val 13152240"/>
             </a:avLst>
           </a:prstGeom>
           <a:noFill/>
@@ -2184,7 +2184,7 @@
                 <a:ea typeface="Cormorant Garamond" pitchFamily="34" charset="-122"/>
                 <a:cs typeface="Cormorant Garamond" pitchFamily="34" charset="-120"/>
               </a:rPr>
-              <a:t>84%</a:t>
+              <a:t>86%</a:t>
             </a:r>
             <a:endParaRPr lang="en-US" sz="3000" dirty="0"/>
           </a:p>
@@ -2268,7 +2268,7 @@
           <a:prstGeom prst="arc">
             <a:avLst>
               <a:gd name="adj1" fmla="val 16200000"/>
-              <a:gd name="adj2" fmla="val 8283600"/>
+              <a:gd name="adj2" fmla="val 9402480"/>
             </a:avLst>
           </a:prstGeom>
           <a:noFill/>
@@ -2313,7 +2313,7 @@
                 <a:ea typeface="Cormorant Garamond" pitchFamily="34" charset="-122"/>
                 <a:cs typeface="Cormorant Garamond" pitchFamily="34" charset="-120"/>
               </a:rPr>
-              <a:t>63%</a:t>
+              <a:t>69%</a:t>
             </a:r>
             <a:endParaRPr lang="en-US" sz="3000" dirty="0"/>
           </a:p>
@@ -3775,7 +3775,7 @@
           <a:prstGeom prst="arc">
             <a:avLst>
               <a:gd name="adj1" fmla="val 16200000"/>
-              <a:gd name="adj2" fmla="val 12711600"/>
+              <a:gd name="adj2" fmla="val 13344480"/>
             </a:avLst>
           </a:prstGeom>
           <a:noFill/>
@@ -3820,7 +3820,7 @@
                 <a:ea typeface="Cormorant Garamond" pitchFamily="34" charset="-122"/>
                 <a:cs typeface="Cormorant Garamond" pitchFamily="34" charset="-120"/>
               </a:rPr>
-              <a:t>84%</a:t>
+              <a:t>87%</a:t>
             </a:r>
             <a:endParaRPr lang="en-US" sz="3000" dirty="0"/>
           </a:p>
@@ -3904,7 +3904,7 @@
           <a:prstGeom prst="arc">
             <a:avLst>
               <a:gd name="adj1" fmla="val 16200000"/>
-              <a:gd name="adj2" fmla="val 11880000"/>
+              <a:gd name="adj2" fmla="val 11061360"/>
             </a:avLst>
           </a:prstGeom>
           <a:noFill/>
@@ -3949,7 +3949,7 @@
                 <a:ea typeface="Cormorant Garamond" pitchFamily="34" charset="-122"/>
                 <a:cs typeface="Cormorant Garamond" pitchFamily="34" charset="-120"/>
               </a:rPr>
-              <a:t>80%</a:t>
+              <a:t>76%</a:t>
             </a:r>
             <a:endParaRPr lang="en-US" sz="3000" dirty="0"/>
           </a:p>
@@ -4033,7 +4033,7 @@
           <a:prstGeom prst="arc">
             <a:avLst>
               <a:gd name="adj1" fmla="val 16200000"/>
-              <a:gd name="adj2" fmla="val 10579680"/>
+              <a:gd name="adj2" fmla="val 12553920"/>
             </a:avLst>
           </a:prstGeom>
           <a:noFill/>
@@ -4078,7 +4078,7 @@
                 <a:ea typeface="Cormorant Garamond" pitchFamily="34" charset="-122"/>
                 <a:cs typeface="Cormorant Garamond" pitchFamily="34" charset="-120"/>
               </a:rPr>
-              <a:t>74%</a:t>
+              <a:t>83%</a:t>
             </a:r>
             <a:endParaRPr lang="en-US" sz="3000" dirty="0"/>
           </a:p>
@@ -4162,7 +4162,7 @@
           <a:prstGeom prst="arc">
             <a:avLst>
               <a:gd name="adj1" fmla="val 16200000"/>
-              <a:gd name="adj2" fmla="val 8156160"/>
+              <a:gd name="adj2" fmla="val 11597040"/>
             </a:avLst>
           </a:prstGeom>
           <a:noFill/>
@@ -4207,7 +4207,7 @@
                 <a:ea typeface="Cormorant Garamond" pitchFamily="34" charset="-122"/>
                 <a:cs typeface="Cormorant Garamond" pitchFamily="34" charset="-120"/>
               </a:rPr>
-              <a:t>63%</a:t>
+              <a:t>79%</a:t>
             </a:r>
             <a:endParaRPr lang="en-US" sz="3000" dirty="0"/>
           </a:p>
@@ -4347,7 +4347,7 @@
                 <a:ea typeface="Segoe UI Light" pitchFamily="34" charset="-122"/>
                 <a:cs typeface="Segoe UI Light" pitchFamily="34" charset="-120"/>
               </a:rPr>
-              <a:t>DeepGlobe is heavily imbalanced. Weighted Dice loss lifts rangeland (34%) and barren (45%) into usefulness.</a:t>
+              <a:t>DeepGlobe is heavily imbalanced. Weighted Dice loss lifts rangeland (35%) and barren (52%) into usefulness.</a:t>
             </a:r>
             <a:endParaRPr lang="en-US" sz="1000" dirty="0"/>
           </a:p>
@@ -4415,7 +4415,7 @@
                 <a:ea typeface="Segoe UI" pitchFamily="34" charset="-122"/>
                 <a:cs typeface="Segoe UI" pitchFamily="34" charset="-120"/>
               </a:rPr>
-              <a:t>84% of all pixels land in the right class</a:t>
+              <a:t>86% of all pixels land in the right class</a:t>
             </a:r>
             <a:pPr indent="0" marL="0">
               <a:buNone/>
@@ -4429,7 +4429,7 @@
                 <a:ea typeface="Segoe UI" pitchFamily="34" charset="-122"/>
                 <a:cs typeface="Segoe UI" pitchFamily="34" charset="-120"/>
               </a:rPr>
-              <a:t>   ·   mean IoU 63% across the six labelled classes, a deliberately strict measure   ·   24 epochs in 41 minutes on one T4</a:t>
+              <a:t>   ·   mean IoU 69% across the six labelled classes, a deliberately strict measure   ·   60 epochs in 150 minutes on one T4</a:t>
             </a:r>
             <a:endParaRPr lang="en-US" sz="1050" dirty="0"/>
           </a:p>

</xml_diff>